<commit_message>
docs(report): atualiza a pasta de entregáveis
</commit_message>
<xml_diff>
--- a/entregaveis-apresentacao/apresentacao.pptx
+++ b/entregaveis-apresentacao/apresentacao.pptx
@@ -919,7 +919,7 @@
           </a:p>
           <a:p>
             <a:r>
-              <a:t>Tempo: 1,6 vez no CIRA e 2,3 vezes no combinado; o tempo de A no CIRA foi medido sob outra carga e, reajustado, é 112,5 s (2,3 vezes).</a:t>
+              <a:t>Tempo: 1,6 vez no CIRA e cerca de 2,2 vezes no combinado; o tempo de A no CIRA foi medido sob outra carga e, reajustado, é 112,5 s (2,3 vezes).</a:t>
             </a:r>
           </a:p>
           <a:p>
@@ -1274,7 +1274,7 @@
           </a:p>
           <a:p>
             <a:r>
-              <a:t>Os experimentos seguintes usam a leitura de profundidade variável como base, porque a outra não prediz uma das classes.</a:t>
+              <a:t>Os experimentos seguintes usam a leitura de profundidade variável como base, porque a outra tem recall 0 em uma das classes.</a:t>
             </a:r>
           </a:p>
           <a:p>
@@ -8255,7 +8255,7 @@
                 </a:solidFill>
                 <a:latin typeface="Proxima Nova"/>
               </a:rPr>
-              <a:t>• Um Random Forest único com peso de classe supera o empilhamento em F1 macro, por 0,5 ponto</a:t>
+              <a:t>• Um Random Forest único com peso de classe supera o empilhamento em F1 macro, por cerca de meio ponto</a:t>
             </a:r>
           </a:p>
           <a:p>

</xml_diff>